<commit_message>
Force all deck fonts to 微軟正黑體 (theme + every run)
Rewrite theme major/minor fonts and hard-set latin/ea/cs typeface on
every run so all text — Latin, numbers, CJK, and inherited layout text
(watermark, page numbers) — renders in 微軟正黑體 per user request.

Co-Authored-By: Claude Opus 4.8 <noreply@anthropic.com>
Claude-Session: https://claude.ai/code/session_01LpgBUWGKF1JKVhPeo8gGmo
</commit_message>
<xml_diff>
--- a/PA team/summaries/PA_Team_市場月報_2026-06-02_to_2026-06-25.pptx
+++ b/PA team/summaries/PA_Team_市場月報_2026-06-02_to_2026-06-25.pptx
@@ -4390,6 +4390,9 @@
                 <a:solidFill>
                   <a:srgbClr val="FFFFFF"/>
                 </a:solidFill>
+                <a:latin typeface="微軟正黑體"/>
+                <a:ea typeface="微軟正黑體"/>
+                <a:cs typeface="微軟正黑體"/>
               </a:rPr>
               <a:t>Portfolio Advisory</a:t>
             </a:r>
@@ -4398,6 +4401,9 @@
                 <a:solidFill>
                   <a:srgbClr val="FFFFFF"/>
                 </a:solidFill>
+                <a:latin typeface="微軟正黑體"/>
+                <a:ea typeface="微軟正黑體"/>
+                <a:cs typeface="微軟正黑體"/>
               </a:rPr>
               <a:t>  晨會重點摘要</a:t>
             </a:r>
@@ -4439,6 +4445,9 @@
                 <a:solidFill>
                   <a:srgbClr val="D9C79F"/>
                 </a:solidFill>
+                <a:latin typeface="微軟正黑體"/>
+                <a:ea typeface="微軟正黑體"/>
+                <a:cs typeface="微軟正黑體"/>
               </a:rPr>
               <a:t>四週市場回顧：AI 盈餘牛市 × 油價衝擊 × 聯儲鷹派轉向</a:t>
             </a:r>
@@ -4480,6 +4489,9 @@
                 <a:solidFill>
                   <a:srgbClr val="FFFFFF"/>
                 </a:solidFill>
+                <a:latin typeface="微軟正黑體"/>
+                <a:ea typeface="微軟正黑體"/>
+                <a:cs typeface="微軟正黑體"/>
               </a:rPr>
               <a:t>彙整期間 2026/06/02 – 06/25　·　12 份每日晨會重點摘要</a:t>
             </a:r>
@@ -4633,6 +4645,9 @@
                 <a:solidFill>
                   <a:srgbClr val="D9C79F"/>
                 </a:solidFill>
+                <a:latin typeface="微軟正黑體"/>
+                <a:ea typeface="微軟正黑體"/>
+                <a:cs typeface="微軟正黑體"/>
               </a:rPr>
               <a:t>私人銀行專屬投組諮詢科</a:t>
             </a:r>
@@ -4677,6 +4692,9 @@
                 <a:solidFill>
                   <a:srgbClr val="222222"/>
                 </a:solidFill>
+                <a:latin typeface="微軟正黑體"/>
+                <a:ea typeface="微軟正黑體"/>
+                <a:cs typeface="微軟正黑體"/>
               </a:rPr>
               <a:t>總覽：四週市場主軸 — 盈餘牛市撞上鷹派轉向</a:t>
             </a:r>
@@ -4762,6 +4780,9 @@
                 <a:solidFill>
                   <a:srgbClr val="222222"/>
                 </a:solidFill>
+                <a:latin typeface="微軟正黑體"/>
+                <a:ea typeface="微軟正黑體"/>
+                <a:cs typeface="微軟正黑體"/>
               </a:rPr>
               <a:t>過去四週（6/2–6/25），市場的核心張力可以一句話概括：</a:t>
             </a:r>
@@ -4770,6 +4791,9 @@
                 <a:solidFill>
                   <a:srgbClr val="222222"/>
                 </a:solidFill>
+                <a:latin typeface="微軟正黑體"/>
+                <a:ea typeface="微軟正黑體"/>
+                <a:cs typeface="微軟正黑體"/>
               </a:rPr>
               <a:t>基本面（企業盈餘）依然強勁，但宏觀環境（通膨與利率）正在轉向</a:t>
             </a:r>
@@ -4778,6 +4802,9 @@
                 <a:solidFill>
                   <a:srgbClr val="222222"/>
                 </a:solidFill>
+                <a:latin typeface="微軟正黑體"/>
+                <a:ea typeface="微軟正黑體"/>
+                <a:cs typeface="微軟正黑體"/>
               </a:rPr>
               <a:t>。月初高盛、德銀與花旗接連上調標普 500 年底目標至 </a:t>
             </a:r>
@@ -4786,6 +4813,9 @@
                 <a:solidFill>
                   <a:srgbClr val="222222"/>
                 </a:solidFill>
+                <a:latin typeface="微軟正黑體"/>
+                <a:ea typeface="微軟正黑體"/>
+                <a:cs typeface="微軟正黑體"/>
               </a:rPr>
               <a:t>8,000–8,100 點</a:t>
             </a:r>
@@ -4794,6 +4824,9 @@
                 <a:solidFill>
                   <a:srgbClr val="222222"/>
                 </a:solidFill>
+                <a:latin typeface="微軟正黑體"/>
+                <a:ea typeface="微軟正黑體"/>
+                <a:cs typeface="微軟正黑體"/>
               </a:rPr>
               <a:t>，AI 資本開支超級週期帶動的盈餘上修是主要動力；然而 </a:t>
             </a:r>
@@ -4802,6 +4835,9 @@
                 <a:solidFill>
                   <a:srgbClr val="222222"/>
                 </a:solidFill>
+                <a:latin typeface="微軟正黑體"/>
+                <a:ea typeface="微軟正黑體"/>
+                <a:cs typeface="微軟正黑體"/>
               </a:rPr>
               <a:t>6/5</a:t>
             </a:r>
@@ -4810,6 +4846,9 @@
                 <a:solidFill>
                   <a:srgbClr val="222222"/>
                 </a:solidFill>
+                <a:latin typeface="微軟正黑體"/>
+                <a:ea typeface="微軟正黑體"/>
+                <a:cs typeface="微軟正黑體"/>
               </a:rPr>
               <a:t> 一場由部位過度擁擠引發的科技股重挫（那斯達克單日 </a:t>
             </a:r>
@@ -4818,6 +4857,9 @@
                 <a:solidFill>
                   <a:srgbClr val="222222"/>
                 </a:solidFill>
+                <a:latin typeface="微軟正黑體"/>
+                <a:ea typeface="微軟正黑體"/>
+                <a:cs typeface="微軟正黑體"/>
               </a:rPr>
               <a:t>−4.18%</a:t>
             </a:r>
@@ -4826,6 +4868,9 @@
                 <a:solidFill>
                   <a:srgbClr val="222222"/>
                 </a:solidFill>
+                <a:latin typeface="微軟正黑體"/>
+                <a:ea typeface="微軟正黑體"/>
+                <a:cs typeface="微軟正黑體"/>
               </a:rPr>
               <a:t>、費半 </a:t>
             </a:r>
@@ -4834,6 +4879,9 @@
                 <a:solidFill>
                   <a:srgbClr val="222222"/>
                 </a:solidFill>
+                <a:latin typeface="微軟正黑體"/>
+                <a:ea typeface="微軟正黑體"/>
+                <a:cs typeface="微軟正黑體"/>
               </a:rPr>
               <a:t>−10.26%</a:t>
             </a:r>
@@ -4842,6 +4890,9 @@
                 <a:solidFill>
                   <a:srgbClr val="222222"/>
                 </a:solidFill>
+                <a:latin typeface="微軟正黑體"/>
+                <a:ea typeface="微軟正黑體"/>
+                <a:cs typeface="微軟正黑體"/>
               </a:rPr>
               <a:t>），揭開了「牛市中場、容錯率極低」的序幕。</a:t>
             </a:r>
@@ -4860,6 +4911,9 @@
                 <a:solidFill>
                   <a:srgbClr val="222222"/>
                 </a:solidFill>
+                <a:latin typeface="微軟正黑體"/>
+                <a:ea typeface="微軟正黑體"/>
+                <a:cs typeface="微軟正黑體"/>
               </a:rPr>
               <a:t>隨後行情圍繞兩條主線拉鋸。其一是</a:t>
             </a:r>
@@ -4868,6 +4922,9 @@
                 <a:solidFill>
                   <a:srgbClr val="222222"/>
                 </a:solidFill>
+                <a:latin typeface="微軟正黑體"/>
+                <a:ea typeface="微軟正黑體"/>
+                <a:cs typeface="微軟正黑體"/>
               </a:rPr>
               <a:t>油價與地緣</a:t>
             </a:r>
@@ -4876,6 +4933,9 @@
                 <a:solidFill>
                   <a:srgbClr val="222222"/>
                 </a:solidFill>
+                <a:latin typeface="微軟正黑體"/>
+                <a:ea typeface="微軟正黑體"/>
+                <a:cs typeface="微軟正黑體"/>
               </a:rPr>
               <a:t>：伊朗戰爭推升通膨，布倫特原油在「基準 86、事故情境 150 美元」之間擺盪，直到 </a:t>
             </a:r>
@@ -4884,6 +4944,9 @@
                 <a:solidFill>
                   <a:srgbClr val="222222"/>
                 </a:solidFill>
+                <a:latin typeface="微軟正黑體"/>
+                <a:ea typeface="微軟正黑體"/>
+                <a:cs typeface="微軟正黑體"/>
               </a:rPr>
               <a:t>6/16</a:t>
             </a:r>
@@ -4892,6 +4955,9 @@
                 <a:solidFill>
                   <a:srgbClr val="222222"/>
                 </a:solidFill>
+                <a:latin typeface="微軟正黑體"/>
+                <a:ea typeface="微軟正黑體"/>
+                <a:cs typeface="微軟正黑體"/>
               </a:rPr>
               <a:t> 美伊達成臨時協議、霍爾木茲海峽重啟在望，油價才回落至 84 美元以下。其二是</a:t>
             </a:r>
@@ -4900,6 +4966,9 @@
                 <a:solidFill>
                   <a:srgbClr val="222222"/>
                 </a:solidFill>
+                <a:latin typeface="微軟正黑體"/>
+                <a:ea typeface="微軟正黑體"/>
+                <a:cs typeface="微軟正黑體"/>
               </a:rPr>
               <a:t>聯儲政策</a:t>
             </a:r>
@@ -4908,6 +4977,9 @@
                 <a:solidFill>
                   <a:srgbClr val="222222"/>
                 </a:solidFill>
+                <a:latin typeface="微軟正黑體"/>
+                <a:ea typeface="微軟正黑體"/>
+                <a:cs typeface="微軟正黑體"/>
               </a:rPr>
               <a:t>：</a:t>
             </a:r>
@@ -4916,6 +4988,9 @@
                 <a:solidFill>
                   <a:srgbClr val="222222"/>
                 </a:solidFill>
+                <a:latin typeface="微軟正黑體"/>
+                <a:ea typeface="微軟正黑體"/>
+                <a:cs typeface="微軟正黑體"/>
               </a:rPr>
               <a:t>6/24</a:t>
             </a:r>
@@ -4924,6 +4999,9 @@
                 <a:solidFill>
                   <a:srgbClr val="222222"/>
                 </a:solidFill>
+                <a:latin typeface="微軟正黑體"/>
+                <a:ea typeface="微軟正黑體"/>
+                <a:cs typeface="微軟正黑體"/>
               </a:rPr>
               <a:t> 沃什（Warsh）主持的首場 FOMC 雖按兵不動，點陣圖卻意外轉鷹，市場將首次加息預期由 2027 年 3 月大幅提前至 </a:t>
             </a:r>
@@ -4932,6 +5010,9 @@
                 <a:solidFill>
                   <a:srgbClr val="222222"/>
                 </a:solidFill>
+                <a:latin typeface="微軟正黑體"/>
+                <a:ea typeface="微軟正黑體"/>
+                <a:cs typeface="微軟正黑體"/>
               </a:rPr>
               <a:t>2026 年 10 月</a:t>
             </a:r>
@@ -4940,6 +5021,9 @@
                 <a:solidFill>
                   <a:srgbClr val="222222"/>
                 </a:solidFill>
+                <a:latin typeface="微軟正黑體"/>
+                <a:ea typeface="微軟正黑體"/>
+                <a:cs typeface="微軟正黑體"/>
               </a:rPr>
               <a:t>，華爾街集體撤回降息押注。</a:t>
             </a:r>
@@ -4958,6 +5042,9 @@
                 <a:solidFill>
                   <a:srgbClr val="222222"/>
                 </a:solidFill>
+                <a:latin typeface="微軟正黑體"/>
+                <a:ea typeface="微軟正黑體"/>
+                <a:cs typeface="微軟正黑體"/>
               </a:rPr>
               <a:t>換言之，這既非單純多頭、也非空頭，而是一個</a:t>
             </a:r>
@@ -4966,6 +5053,9 @@
                 <a:solidFill>
                   <a:srgbClr val="222222"/>
                 </a:solidFill>
+                <a:latin typeface="微軟正黑體"/>
+                <a:ea typeface="微軟正黑體"/>
+                <a:cs typeface="微軟正黑體"/>
               </a:rPr>
               <a:t>「相信 AI 敘事」與「預期透支」相互拉扯</a:t>
             </a:r>
@@ -4974,6 +5064,9 @@
                 <a:solidFill>
                   <a:srgbClr val="222222"/>
                 </a:solidFill>
+                <a:latin typeface="微軟正黑體"/>
+                <a:ea typeface="微軟正黑體"/>
+                <a:cs typeface="微軟正黑體"/>
               </a:rPr>
               <a:t>的市場：盈餘的確定性仍支撐估值，但擁擠度創歷史新高、利率逼近紅線，使任何利空都可能被槓桿與波動率放大。</a:t>
             </a:r>
@@ -5103,6 +5196,9 @@
                 <a:solidFill>
                   <a:srgbClr val="FFFFFF"/>
                 </a:solidFill>
+                <a:latin typeface="微軟正黑體"/>
+                <a:ea typeface="微軟正黑體"/>
+                <a:cs typeface="微軟正黑體"/>
               </a:rPr>
               <a:t>四週關鍵節點</a:t>
             </a:r>
@@ -5144,6 +5240,9 @@
                 <a:solidFill>
                   <a:srgbClr val="977B3B"/>
                 </a:solidFill>
+                <a:latin typeface="微軟正黑體"/>
+                <a:ea typeface="微軟正黑體"/>
+                <a:cs typeface="微軟正黑體"/>
               </a:rPr>
               <a:t>6/02–04</a:t>
             </a:r>
@@ -5185,6 +5284,9 @@
                 <a:solidFill>
                   <a:srgbClr val="222222"/>
                 </a:solidFill>
+                <a:latin typeface="微軟正黑體"/>
+                <a:ea typeface="微軟正黑體"/>
+                <a:cs typeface="微軟正黑體"/>
               </a:rPr>
               <a:t>「1999 遇上 1990」：AI 熱潮撞上油價衝擊，GS/DB 上調標普目標至 8000</a:t>
             </a:r>
@@ -5226,6 +5328,9 @@
                 <a:solidFill>
                   <a:srgbClr val="977B3B"/>
                 </a:solidFill>
+                <a:latin typeface="微軟正黑體"/>
+                <a:ea typeface="微軟正黑體"/>
+                <a:cs typeface="微軟正黑體"/>
               </a:rPr>
               <a:t>6/05</a:t>
             </a:r>
@@ -5267,6 +5372,9 @@
                 <a:solidFill>
                   <a:srgbClr val="222222"/>
                 </a:solidFill>
+                <a:latin typeface="微軟正黑體"/>
+                <a:ea typeface="微軟正黑體"/>
+                <a:cs typeface="微軟正黑體"/>
               </a:rPr>
               <a:t>科技重挫：那指 −4.18%、費半 −10.26%，逾兆美元蒸發，韓股熔斷</a:t>
             </a:r>
@@ -5308,6 +5416,9 @@
                 <a:solidFill>
                   <a:srgbClr val="977B3B"/>
                 </a:solidFill>
+                <a:latin typeface="微軟正黑體"/>
+                <a:ea typeface="微軟正黑體"/>
+                <a:cs typeface="微軟正黑體"/>
               </a:rPr>
               <a:t>6/09–11</a:t>
             </a:r>
@@ -5349,6 +5460,9 @@
                 <a:solidFill>
                   <a:srgbClr val="222222"/>
                 </a:solidFill>
+                <a:latin typeface="微軟正黑體"/>
+                <a:ea typeface="微軟正黑體"/>
+                <a:cs typeface="微軟正黑體"/>
               </a:rPr>
               <a:t>「健康調整」非見頂；惟大摩流動性指標轉緊</a:t>
             </a:r>
@@ -5390,6 +5504,9 @@
                 <a:solidFill>
                   <a:srgbClr val="977B3B"/>
                 </a:solidFill>
+                <a:latin typeface="微軟正黑體"/>
+                <a:ea typeface="微軟正黑體"/>
+                <a:cs typeface="微軟正黑體"/>
               </a:rPr>
               <a:t>6/16–17</a:t>
             </a:r>
@@ -5431,6 +5548,9 @@
                 <a:solidFill>
                   <a:srgbClr val="222222"/>
                 </a:solidFill>
+                <a:latin typeface="微軟正黑體"/>
+                <a:ea typeface="微軟正黑體"/>
+                <a:cs typeface="微軟正黑體"/>
               </a:rPr>
               <a:t>美伊臨時協議，布倫特跌破 84；大型科技去擁擠回中性</a:t>
             </a:r>
@@ -5472,6 +5592,9 @@
                 <a:solidFill>
                   <a:srgbClr val="977B3B"/>
                 </a:solidFill>
+                <a:latin typeface="微軟正黑體"/>
+                <a:ea typeface="微軟正黑體"/>
+                <a:cs typeface="微軟正黑體"/>
               </a:rPr>
               <a:t>6/18</a:t>
             </a:r>
@@ -5513,6 +5636,9 @@
                 <a:solidFill>
                   <a:srgbClr val="222222"/>
                 </a:solidFill>
+                <a:latin typeface="微軟正黑體"/>
+                <a:ea typeface="微軟正黑體"/>
+                <a:cs typeface="微軟正黑體"/>
               </a:rPr>
               <a:t>擁擠度創高：做多半導體＝史上最擁擠（80%），現金升至 4.1%</a:t>
             </a:r>
@@ -5554,6 +5680,9 @@
                 <a:solidFill>
                   <a:srgbClr val="977B3B"/>
                 </a:solidFill>
+                <a:latin typeface="微軟正黑體"/>
+                <a:ea typeface="微軟正黑體"/>
+                <a:cs typeface="微軟正黑體"/>
               </a:rPr>
               <a:t>6/24</a:t>
             </a:r>
@@ -5595,6 +5724,9 @@
                 <a:solidFill>
                   <a:srgbClr val="222222"/>
                 </a:solidFill>
+                <a:latin typeface="微軟正黑體"/>
+                <a:ea typeface="微軟正黑體"/>
+                <a:cs typeface="微軟正黑體"/>
               </a:rPr>
               <a:t>FOMC 鷹派轉向：首次加息預期提前至 2026/10</a:t>
             </a:r>
@@ -5636,6 +5768,9 @@
                 <a:solidFill>
                   <a:srgbClr val="977B3B"/>
                 </a:solidFill>
+                <a:latin typeface="微軟正黑體"/>
+                <a:ea typeface="微軟正黑體"/>
+                <a:cs typeface="微軟正黑體"/>
               </a:rPr>
               <a:t>6/25</a:t>
             </a:r>
@@ -5677,6 +5812,9 @@
                 <a:solidFill>
                   <a:srgbClr val="222222"/>
                 </a:solidFill>
+                <a:latin typeface="微軟正黑體"/>
+                <a:ea typeface="微軟正黑體"/>
+                <a:cs typeface="微軟正黑體"/>
               </a:rPr>
               <a:t>資產配置防禦微調：美股超配、歐能源降中性、偏好中期美債</a:t>
             </a:r>
@@ -5718,6 +5856,9 @@
                 <a:solidFill>
                   <a:srgbClr val="6A7C8D"/>
                 </a:solidFill>
+                <a:latin typeface="微軟正黑體"/>
+                <a:ea typeface="微軟正黑體"/>
+                <a:cs typeface="微軟正黑體"/>
               </a:rPr>
               <a:t>資料來源：Goldman Sachs / Morgan Stanley / Deutsche Bank / Citi / BofA / Bloomberg（PA 晨會摘要 2026/06）</a:t>
             </a:r>
@@ -5762,6 +5903,9 @@
                 <a:solidFill>
                   <a:srgbClr val="222222"/>
                 </a:solidFill>
+                <a:latin typeface="微軟正黑體"/>
+                <a:ea typeface="微軟正黑體"/>
+                <a:cs typeface="微軟正黑體"/>
               </a:rPr>
               <a:t>主題一：AI 盈餘牛市 — 中場，但窗口正在收窄</a:t>
             </a:r>
@@ -5847,6 +5991,9 @@
                 <a:solidFill>
                   <a:srgbClr val="222222"/>
                 </a:solidFill>
+                <a:latin typeface="微軟正黑體"/>
+                <a:ea typeface="微軟正黑體"/>
+                <a:cs typeface="微軟正黑體"/>
               </a:rPr>
               <a:t>本輪美股的核心驅動力，是一場被花旗形容為「史無前例」的 AI 資本開支超級週期。與 1999 年或 2021 年的純情緒行情不同，這次有紮實的盈餘背書：標普 500 第一季實際盈餘較市場共識高出約 </a:t>
             </a:r>
@@ -5855,6 +6002,9 @@
                 <a:solidFill>
                   <a:srgbClr val="222222"/>
                 </a:solidFill>
+                <a:latin typeface="微軟正黑體"/>
+                <a:ea typeface="微軟正黑體"/>
+                <a:cs typeface="微軟正黑體"/>
               </a:rPr>
               <a:t>13%</a:t>
             </a:r>
@@ -5863,6 +6013,9 @@
                 <a:solidFill>
                   <a:srgbClr val="222222"/>
                 </a:solidFill>
+                <a:latin typeface="微軟正黑體"/>
+                <a:ea typeface="微軟正黑體"/>
+                <a:cs typeface="微軟正黑體"/>
               </a:rPr>
               <a:t>，2026 年每股盈餘預估自 320 美元一路上修至 </a:t>
             </a:r>
@@ -5871,6 +6024,9 @@
                 <a:solidFill>
                   <a:srgbClr val="222222"/>
                 </a:solidFill>
+                <a:latin typeface="微軟正黑體"/>
+                <a:ea typeface="微軟正黑體"/>
+                <a:cs typeface="微軟正黑體"/>
               </a:rPr>
               <a:t>340–350 美元</a:t>
             </a:r>
@@ -5879,6 +6035,9 @@
                 <a:solidFill>
                   <a:srgbClr val="222222"/>
                 </a:solidFill>
+                <a:latin typeface="微軟正黑體"/>
+                <a:ea typeface="微軟正黑體"/>
+                <a:cs typeface="微軟正黑體"/>
               </a:rPr>
               <a:t>，2027 年上看 </a:t>
             </a:r>
@@ -5887,6 +6046,9 @@
                 <a:solidFill>
                   <a:srgbClr val="222222"/>
                 </a:solidFill>
+                <a:latin typeface="微軟正黑體"/>
+                <a:ea typeface="微軟正黑體"/>
+                <a:cs typeface="微軟正黑體"/>
               </a:rPr>
               <a:t>385–400 美元</a:t>
             </a:r>
@@ -5895,6 +6057,9 @@
                 <a:solidFill>
                   <a:srgbClr val="222222"/>
                 </a:solidFill>
+                <a:latin typeface="微軟正黑體"/>
+                <a:ea typeface="微軟正黑體"/>
+                <a:cs typeface="微軟正黑體"/>
               </a:rPr>
               <a:t>。高盛、花旗因而分別將年底目標上調至 </a:t>
             </a:r>
@@ -5903,6 +6068,9 @@
                 <a:solidFill>
                   <a:srgbClr val="222222"/>
                 </a:solidFill>
+                <a:latin typeface="微軟正黑體"/>
+                <a:ea typeface="微軟正黑體"/>
+                <a:cs typeface="微軟正黑體"/>
               </a:rPr>
               <a:t>8,000、8,100 點</a:t>
             </a:r>
@@ -5911,6 +6079,9 @@
                 <a:solidFill>
                   <a:srgbClr val="222222"/>
                 </a:solidFill>
+                <a:latin typeface="微軟正黑體"/>
+                <a:ea typeface="微軟正黑體"/>
+                <a:cs typeface="微軟正黑體"/>
               </a:rPr>
               <a:t>，大摩更給出 2027 年中 </a:t>
             </a:r>
@@ -5919,6 +6090,9 @@
                 <a:solidFill>
                   <a:srgbClr val="222222"/>
                 </a:solidFill>
+                <a:latin typeface="微軟正黑體"/>
+                <a:ea typeface="微軟正黑體"/>
+                <a:cs typeface="微軟正黑體"/>
               </a:rPr>
               <a:t>8,300 點</a:t>
             </a:r>
@@ -5927,6 +6101,9 @@
                 <a:solidFill>
                   <a:srgbClr val="222222"/>
                 </a:solidFill>
+                <a:latin typeface="微軟正黑體"/>
+                <a:ea typeface="微軟正黑體"/>
+                <a:cs typeface="微軟正黑體"/>
               </a:rPr>
               <a:t>目標。</a:t>
             </a:r>
@@ -5945,6 +6122,9 @@
                 <a:solidFill>
                   <a:srgbClr val="222222"/>
                 </a:solidFill>
+                <a:latin typeface="微軟正黑體"/>
+                <a:ea typeface="微軟正黑體"/>
+                <a:cs typeface="微軟正黑體"/>
               </a:rPr>
               <a:t>但多家投行同時示警「窗口正在收窄」。後續上漲須靠盈餘、而非估值擴張推動——新目標隱含的本益比（約 20–23 倍）反而較先前更低；最快的盈餘增速可能已過，正向驚喜將逐步收斂，形成一個</a:t>
             </a:r>
@@ -5953,6 +6133,9 @@
                 <a:solidFill>
                   <a:srgbClr val="222222"/>
                 </a:solidFill>
+                <a:latin typeface="微軟正黑體"/>
+                <a:ea typeface="微軟正黑體"/>
+                <a:cs typeface="微軟正黑體"/>
               </a:rPr>
               <a:t>容錯率極低</a:t>
             </a:r>
@@ -5961,6 +6144,9 @@
                 <a:solidFill>
                   <a:srgbClr val="222222"/>
                 </a:solidFill>
+                <a:latin typeface="微軟正黑體"/>
+                <a:ea typeface="微軟正黑體"/>
+                <a:cs typeface="微軟正黑體"/>
               </a:rPr>
               <a:t>的市場。</a:t>
             </a:r>
@@ -5979,6 +6165,9 @@
                 <a:solidFill>
                   <a:srgbClr val="222222"/>
                 </a:solidFill>
+                <a:latin typeface="微軟正黑體"/>
+                <a:ea typeface="微軟正黑體"/>
+                <a:cs typeface="微軟正黑體"/>
               </a:rPr>
               <a:t>更值得警惕的是集中度：AI 相關個股已佔標普 500 權重達 </a:t>
             </a:r>
@@ -5987,6 +6176,9 @@
                 <a:solidFill>
                   <a:srgbClr val="222222"/>
                 </a:solidFill>
+                <a:latin typeface="微軟正黑體"/>
+                <a:ea typeface="微軟正黑體"/>
+                <a:cs typeface="微軟正黑體"/>
               </a:rPr>
               <a:t>39%</a:t>
             </a:r>
@@ -5995,6 +6187,9 @@
                 <a:solidFill>
                   <a:srgbClr val="222222"/>
                 </a:solidFill>
+                <a:latin typeface="微軟正黑體"/>
+                <a:ea typeface="微軟正黑體"/>
+                <a:cs typeface="微軟正黑體"/>
               </a:rPr>
               <a:t>。當「賣鏟子」（AI 基礎設施）邏輯被市場充分認識後，下行風險呈現不對稱放大——越是眾所周知的主題，一旦增速放緩，定價逆轉就越快。這正是後續配置須主動分散、降低集中的根本原因。</a:t>
             </a:r>
@@ -6039,6 +6234,9 @@
                           <a:solidFill>
                             <a:srgbClr val="FFFFFF"/>
                           </a:solidFill>
+                          <a:latin typeface="微軟正黑體"/>
+                          <a:ea typeface="微軟正黑體"/>
+                          <a:cs typeface="微軟正黑體"/>
                         </a:rPr>
                         <a:t>指標</a:t>
                       </a:r>
@@ -6065,6 +6263,9 @@
                           <a:solidFill>
                             <a:srgbClr val="FFFFFF"/>
                           </a:solidFill>
+                          <a:latin typeface="微軟正黑體"/>
+                          <a:ea typeface="微軟正黑體"/>
+                          <a:cs typeface="微軟正黑體"/>
                         </a:rPr>
                         <a:t>現況</a:t>
                       </a:r>
@@ -6093,6 +6294,9 @@
                           <a:solidFill>
                             <a:srgbClr val="222222"/>
                           </a:solidFill>
+                          <a:latin typeface="微軟正黑體"/>
+                          <a:ea typeface="微軟正黑體"/>
+                          <a:cs typeface="微軟正黑體"/>
                         </a:rPr>
                         <a:t>標普目標</a:t>
                       </a:r>
@@ -6119,6 +6323,9 @@
                           <a:solidFill>
                             <a:srgbClr val="222222"/>
                           </a:solidFill>
+                          <a:latin typeface="微軟正黑體"/>
+                          <a:ea typeface="微軟正黑體"/>
+                          <a:cs typeface="微軟正黑體"/>
                         </a:rPr>
                         <a:t>GS 8000・Citi 8100・DB 8000</a:t>
                       </a:r>
@@ -6147,6 +6354,9 @@
                           <a:solidFill>
                             <a:srgbClr val="222222"/>
                           </a:solidFill>
+                          <a:latin typeface="微軟正黑體"/>
+                          <a:ea typeface="微軟正黑體"/>
+                          <a:cs typeface="微軟正黑體"/>
                         </a:rPr>
                         <a:t>（大摩）</a:t>
                       </a:r>
@@ -6173,6 +6383,9 @@
                           <a:solidFill>
                             <a:srgbClr val="222222"/>
                           </a:solidFill>
+                          <a:latin typeface="微軟正黑體"/>
+                          <a:ea typeface="微軟正黑體"/>
+                          <a:cs typeface="微軟正黑體"/>
                         </a:rPr>
                         <a:t>MS 8300（2027 年中）</a:t>
                       </a:r>
@@ -6201,6 +6414,9 @@
                           <a:solidFill>
                             <a:srgbClr val="222222"/>
                           </a:solidFill>
+                          <a:latin typeface="微軟正黑體"/>
+                          <a:ea typeface="微軟正黑體"/>
+                          <a:cs typeface="微軟正黑體"/>
                         </a:rPr>
                         <a:t>2026 EPS</a:t>
                       </a:r>
@@ -6227,6 +6443,9 @@
                           <a:solidFill>
                             <a:srgbClr val="222222"/>
                           </a:solidFill>
+                          <a:latin typeface="微軟正黑體"/>
+                          <a:ea typeface="微軟正黑體"/>
+                          <a:cs typeface="微軟正黑體"/>
                         </a:rPr>
                         <a:t>340–350 美元（↑自 320）</a:t>
                       </a:r>
@@ -6255,6 +6474,9 @@
                           <a:solidFill>
                             <a:srgbClr val="222222"/>
                           </a:solidFill>
+                          <a:latin typeface="微軟正黑體"/>
+                          <a:ea typeface="微軟正黑體"/>
+                          <a:cs typeface="微軟正黑體"/>
                         </a:rPr>
                         <a:t>2027 EPS</a:t>
                       </a:r>
@@ -6281,6 +6503,9 @@
                           <a:solidFill>
                             <a:srgbClr val="222222"/>
                           </a:solidFill>
+                          <a:latin typeface="微軟正黑體"/>
+                          <a:ea typeface="微軟正黑體"/>
+                          <a:cs typeface="微軟正黑體"/>
                         </a:rPr>
                         <a:t>385–400 美元</a:t>
                       </a:r>
@@ -6309,6 +6534,9 @@
                           <a:solidFill>
                             <a:srgbClr val="222222"/>
                           </a:solidFill>
+                          <a:latin typeface="微軟正黑體"/>
+                          <a:ea typeface="微軟正黑體"/>
+                          <a:cs typeface="微軟正黑體"/>
                         </a:rPr>
                         <a:t>Q1 盈餘</a:t>
                       </a:r>
@@ -6335,6 +6563,9 @@
                           <a:solidFill>
                             <a:srgbClr val="222222"/>
                           </a:solidFill>
+                          <a:latin typeface="微軟正黑體"/>
+                          <a:ea typeface="微軟正黑體"/>
+                          <a:cs typeface="微軟正黑體"/>
                         </a:rPr>
                         <a:t>較市場共識高約 13%</a:t>
                       </a:r>
@@ -6363,6 +6594,9 @@
                           <a:solidFill>
                             <a:srgbClr val="222222"/>
                           </a:solidFill>
+                          <a:latin typeface="微軟正黑體"/>
+                          <a:ea typeface="微軟正黑體"/>
+                          <a:cs typeface="微軟正黑體"/>
                         </a:rPr>
                         <a:t>AI 權重</a:t>
                       </a:r>
@@ -6389,6 +6623,9 @@
                           <a:solidFill>
                             <a:srgbClr val="222222"/>
                           </a:solidFill>
+                          <a:latin typeface="微軟正黑體"/>
+                          <a:ea typeface="微軟正黑體"/>
+                          <a:cs typeface="微軟正黑體"/>
                         </a:rPr>
                         <a:t>佔標普 500 約 39%</a:t>
                       </a:r>
@@ -6417,6 +6654,9 @@
                           <a:solidFill>
                             <a:srgbClr val="222222"/>
                           </a:solidFill>
+                          <a:latin typeface="微軟正黑體"/>
+                          <a:ea typeface="微軟正黑體"/>
+                          <a:cs typeface="微軟正黑體"/>
                         </a:rPr>
                         <a:t>本益比</a:t>
                       </a:r>
@@ -6443,6 +6683,9 @@
                           <a:solidFill>
                             <a:srgbClr val="222222"/>
                           </a:solidFill>
+                          <a:latin typeface="微軟正黑體"/>
+                          <a:ea typeface="微軟正黑體"/>
+                          <a:cs typeface="微軟正黑體"/>
                         </a:rPr>
                         <a:t>約 20–23 倍（隨盈餘上修而降）</a:t>
                       </a:r>
@@ -6494,6 +6737,9 @@
                 <a:solidFill>
                   <a:srgbClr val="6A7C8D"/>
                 </a:solidFill>
+                <a:latin typeface="微軟正黑體"/>
+                <a:ea typeface="微軟正黑體"/>
+                <a:cs typeface="微軟正黑體"/>
               </a:rPr>
               <a:t>資料來源：Goldman Sachs / Citi / Morgan Stanley（PA 晨會摘要 2026/06）</a:t>
             </a:r>
@@ -6538,6 +6784,9 @@
                 <a:solidFill>
                   <a:srgbClr val="222222"/>
                 </a:solidFill>
+                <a:latin typeface="微軟正黑體"/>
+                <a:ea typeface="微軟正黑體"/>
+                <a:cs typeface="微軟正黑體"/>
               </a:rPr>
               <a:t>主題二：通膨回溫與聯儲鷹派轉向 — 1996 還是 1999？</a:t>
             </a:r>
@@ -6623,6 +6872,9 @@
                 <a:solidFill>
                   <a:srgbClr val="222222"/>
                 </a:solidFill>
+                <a:latin typeface="微軟正黑體"/>
+                <a:ea typeface="微軟正黑體"/>
+                <a:cs typeface="微軟正黑體"/>
               </a:rPr>
               <a:t>這段期間最關鍵的宏觀轉折，是</a:t>
             </a:r>
@@ -6631,6 +6883,9 @@
                 <a:solidFill>
                   <a:srgbClr val="222222"/>
                 </a:solidFill>
+                <a:latin typeface="微軟正黑體"/>
+                <a:ea typeface="微軟正黑體"/>
+                <a:cs typeface="微軟正黑體"/>
               </a:rPr>
               <a:t>通膨預期回溫與聯儲態度轉鷹</a:t>
             </a:r>
@@ -6639,6 +6894,9 @@
                 <a:solidFill>
                   <a:srgbClr val="222222"/>
                 </a:solidFill>
+                <a:latin typeface="微軟正黑體"/>
+                <a:ea typeface="微軟正黑體"/>
+                <a:cs typeface="微軟正黑體"/>
               </a:rPr>
               <a:t>。德銀以「1999 遇上 1990」形容當前處境——AI 熱潮像 1999、油價衝擊像 1990；其最新預測中增長僅小幅下修、通膨卻大幅上修，名義 GDP 被通膨托高，迫使央行週期轉向。轉折點落在 </a:t>
             </a:r>
@@ -6647,6 +6905,9 @@
                 <a:solidFill>
                   <a:srgbClr val="222222"/>
                 </a:solidFill>
+                <a:latin typeface="微軟正黑體"/>
+                <a:ea typeface="微軟正黑體"/>
+                <a:cs typeface="微軟正黑體"/>
               </a:rPr>
               <a:t>6/24</a:t>
             </a:r>
@@ -6655,6 +6916,9 @@
                 <a:solidFill>
                   <a:srgbClr val="222222"/>
                 </a:solidFill>
+                <a:latin typeface="微軟正黑體"/>
+                <a:ea typeface="微軟正黑體"/>
+                <a:cs typeface="微軟正黑體"/>
               </a:rPr>
               <a:t>：沃什主持的首場 FOMC 維持利率不變，但點陣圖意外轉鷹（</a:t>
             </a:r>
@@ -6663,6 +6927,9 @@
                 <a:solidFill>
                   <a:srgbClr val="222222"/>
                 </a:solidFill>
+                <a:latin typeface="微軟正黑體"/>
+                <a:ea typeface="微軟正黑體"/>
+                <a:cs typeface="微軟正黑體"/>
               </a:rPr>
               <a:t>18 位官員中 9 位</a:t>
             </a:r>
@@ -6671,6 +6938,9 @@
                 <a:solidFill>
                   <a:srgbClr val="222222"/>
                 </a:solidFill>
+                <a:latin typeface="微軟正黑體"/>
+                <a:ea typeface="微軟正黑體"/>
+                <a:cs typeface="微軟正黑體"/>
               </a:rPr>
               <a:t>指向年內加息），並刪除「寬鬆偏向」措辭、拒絕提供前瞻指引。掉期市場隨即將首次加息預期由 2027 年 3 月提前至 </a:t>
             </a:r>
@@ -6679,6 +6949,9 @@
                 <a:solidFill>
                   <a:srgbClr val="222222"/>
                 </a:solidFill>
+                <a:latin typeface="微軟正黑體"/>
+                <a:ea typeface="微軟正黑體"/>
+                <a:cs typeface="微軟正黑體"/>
               </a:rPr>
               <a:t>2026 年 10 月</a:t>
             </a:r>
@@ -6687,6 +6960,9 @@
                 <a:solidFill>
                   <a:srgbClr val="222222"/>
                 </a:solidFill>
+                <a:latin typeface="微軟正黑體"/>
+                <a:ea typeface="微軟正黑體"/>
+                <a:cs typeface="微軟正黑體"/>
               </a:rPr>
               <a:t>，年內已定價約 </a:t>
             </a:r>
@@ -6695,6 +6971,9 @@
                 <a:solidFill>
                   <a:srgbClr val="222222"/>
                 </a:solidFill>
+                <a:latin typeface="微軟正黑體"/>
+                <a:ea typeface="微軟正黑體"/>
+                <a:cs typeface="微軟正黑體"/>
               </a:rPr>
               <a:t>41 個基點</a:t>
             </a:r>
@@ -6703,6 +6982,9 @@
                 <a:solidFill>
                   <a:srgbClr val="222222"/>
                 </a:solidFill>
+                <a:latin typeface="微軟正黑體"/>
+                <a:ea typeface="微軟正黑體"/>
+                <a:cs typeface="微軟正黑體"/>
               </a:rPr>
               <a:t>，2 年期美債殖利率創 3 月以來最大單日漲幅。</a:t>
             </a:r>
@@ -6721,6 +7003,9 @@
                 <a:solidFill>
                   <a:srgbClr val="222222"/>
                 </a:solidFill>
+                <a:latin typeface="微軟正黑體"/>
+                <a:ea typeface="微軟正黑體"/>
+                <a:cs typeface="微軟正黑體"/>
               </a:rPr>
               <a:t>市場的核心辯論，是這輪 AI 繁榮究竟是 </a:t>
             </a:r>
@@ -6729,6 +7014,9 @@
                 <a:solidFill>
                   <a:srgbClr val="222222"/>
                 </a:solidFill>
+                <a:latin typeface="微軟正黑體"/>
+                <a:ea typeface="微軟正黑體"/>
+                <a:cs typeface="微軟正黑體"/>
               </a:rPr>
               <a:t>1996（生產率紅利，可從容按兵不動）還是 1999（需求過熱，須預先收緊）</a:t>
             </a:r>
@@ -6737,6 +7025,9 @@
                 <a:solidFill>
                   <a:srgbClr val="222222"/>
                 </a:solidFill>
+                <a:latin typeface="微軟正黑體"/>
+                <a:ea typeface="微軟正黑體"/>
+                <a:cs typeface="微軟正黑體"/>
               </a:rPr>
               <a:t>。沃什明顯傾向 1996 劇本，但面對關稅、財政赤字擴張與全球化紅利消退，其通膨壓力大於格林斯潘當年——這也使各大投行對聯儲路徑出現罕見分歧：</a:t>
             </a:r>
@@ -6781,6 +7072,9 @@
                           <a:solidFill>
                             <a:srgbClr val="FFFFFF"/>
                           </a:solidFill>
+                          <a:latin typeface="微軟正黑體"/>
+                          <a:ea typeface="微軟正黑體"/>
+                          <a:cs typeface="微軟正黑體"/>
                         </a:rPr>
                         <a:t>機構</a:t>
                       </a:r>
@@ -6807,6 +7101,9 @@
                           <a:solidFill>
                             <a:srgbClr val="FFFFFF"/>
                           </a:solidFill>
+                          <a:latin typeface="微軟正黑體"/>
+                          <a:ea typeface="微軟正黑體"/>
+                          <a:cs typeface="微軟正黑體"/>
                         </a:rPr>
                         <a:t>對聯儲路徑的看法</a:t>
                       </a:r>
@@ -6835,6 +7132,9 @@
                           <a:solidFill>
                             <a:srgbClr val="222222"/>
                           </a:solidFill>
+                          <a:latin typeface="微軟正黑體"/>
+                          <a:ea typeface="微軟正黑體"/>
+                          <a:cs typeface="微軟正黑體"/>
                         </a:rPr>
                         <a:t>美銀 BofA</a:t>
                       </a:r>
@@ -6861,6 +7161,9 @@
                           <a:solidFill>
                             <a:srgbClr val="222222"/>
                           </a:solidFill>
+                          <a:latin typeface="微軟正黑體"/>
+                          <a:ea typeface="微軟正黑體"/>
+                          <a:cs typeface="微軟正黑體"/>
                         </a:rPr>
                         <a:t>年內加息 3 碼（9/10/12 月，共 +75bp）；維持「逢高減倉」</a:t>
                       </a:r>
@@ -6889,6 +7192,9 @@
                           <a:solidFill>
                             <a:srgbClr val="222222"/>
                           </a:solidFill>
+                          <a:latin typeface="微軟正黑體"/>
+                          <a:ea typeface="微軟正黑體"/>
+                          <a:cs typeface="微軟正黑體"/>
                         </a:rPr>
                         <a:t>德銀 DB</a:t>
                       </a:r>
@@ -6915,6 +7221,9 @@
                           <a:solidFill>
                             <a:srgbClr val="222222"/>
                           </a:solidFill>
+                          <a:latin typeface="微軟正黑體"/>
+                          <a:ea typeface="微軟正黑體"/>
+                          <a:cs typeface="微軟正黑體"/>
                         </a:rPr>
                         <a:t>年內加息 2 碼至 4.1%，警告 7 月可能提前</a:t>
                       </a:r>
@@ -6943,6 +7252,9 @@
                           <a:solidFill>
                             <a:srgbClr val="222222"/>
                           </a:solidFill>
+                          <a:latin typeface="微軟正黑體"/>
+                          <a:ea typeface="微軟正黑體"/>
+                          <a:cs typeface="微軟正黑體"/>
                         </a:rPr>
                         <a:t>巴克萊 Barclays</a:t>
                       </a:r>
@@ -6969,6 +7281,9 @@
                           <a:solidFill>
                             <a:srgbClr val="222222"/>
                           </a:solidFill>
+                          <a:latin typeface="微軟正黑體"/>
+                          <a:ea typeface="微軟正黑體"/>
+                          <a:cs typeface="微軟正黑體"/>
                         </a:rPr>
                         <a:t>建議做空美債，殖利率曲線「熊陡」，各天期目標上調約 35bp</a:t>
                       </a:r>
@@ -6997,6 +7312,9 @@
                           <a:solidFill>
                             <a:srgbClr val="222222"/>
                           </a:solidFill>
+                          <a:latin typeface="微軟正黑體"/>
+                          <a:ea typeface="微軟正黑體"/>
+                          <a:cs typeface="微軟正黑體"/>
                         </a:rPr>
                         <a:t>花旗 Citi</a:t>
                       </a:r>
@@ -7023,6 +7341,9 @@
                           <a:solidFill>
                             <a:srgbClr val="222222"/>
                           </a:solidFill>
+                          <a:latin typeface="微軟正黑體"/>
+                          <a:ea typeface="微軟正黑體"/>
+                          <a:cs typeface="微軟正黑體"/>
                         </a:rPr>
                         <a:t>逆勢，仍看降息（10/12 月、明年 1 月各 −25bp）</a:t>
                       </a:r>
@@ -7051,6 +7372,9 @@
                           <a:solidFill>
                             <a:srgbClr val="222222"/>
                           </a:solidFill>
+                          <a:latin typeface="微軟正黑體"/>
+                          <a:ea typeface="微軟正黑體"/>
+                          <a:cs typeface="微軟正黑體"/>
                         </a:rPr>
                         <a:t>大摩 MS</a:t>
                       </a:r>
@@ -7077,6 +7401,9 @@
                           <a:solidFill>
                             <a:srgbClr val="222222"/>
                           </a:solidFill>
+                          <a:latin typeface="微軟正黑體"/>
+                          <a:ea typeface="微軟正黑體"/>
+                          <a:cs typeface="微軟正黑體"/>
                         </a:rPr>
                         <a:t>今年按兵不動，明年第一季降息 1 碼</a:t>
                       </a:r>
@@ -7128,6 +7455,9 @@
                 <a:solidFill>
                   <a:srgbClr val="6A7C8D"/>
                 </a:solidFill>
+                <a:latin typeface="微軟正黑體"/>
+                <a:ea typeface="微軟正黑體"/>
+                <a:cs typeface="微軟正黑體"/>
               </a:rPr>
               <a:t>資料來源：BofA / Deutsche Bank / Barclays / Citi / Morgan Stanley（PA 晨會摘要 2026/06）</a:t>
             </a:r>
@@ -7172,6 +7502,9 @@
                 <a:solidFill>
                   <a:srgbClr val="222222"/>
                 </a:solidFill>
+                <a:latin typeface="微軟正黑體"/>
+                <a:ea typeface="微軟正黑體"/>
+                <a:cs typeface="微軟正黑體"/>
               </a:rPr>
               <a:t>主題三：油價是「總開關」，利率是「紅線」</a:t>
             </a:r>
@@ -7257,6 +7590,9 @@
                 <a:solidFill>
                   <a:srgbClr val="222222"/>
                 </a:solidFill>
+                <a:latin typeface="微軟正黑體"/>
+                <a:ea typeface="微軟正黑體"/>
+                <a:cs typeface="微軟正黑體"/>
               </a:rPr>
               <a:t>若說盈餘決定市場的高度，那麼</a:t>
             </a:r>
@@ -7265,6 +7601,9 @@
                 <a:solidFill>
                   <a:srgbClr val="222222"/>
                 </a:solidFill>
+                <a:latin typeface="微軟正黑體"/>
+                <a:ea typeface="微軟正黑體"/>
+                <a:cs typeface="微軟正黑體"/>
               </a:rPr>
               <a:t>油價與利率，就決定了市場的下檔風險</a:t>
             </a:r>
@@ -7273,6 +7612,9 @@
                 <a:solidFill>
                   <a:srgbClr val="222222"/>
                 </a:solidFill>
+                <a:latin typeface="微軟正黑體"/>
+                <a:ea typeface="微軟正黑體"/>
+                <a:cs typeface="微軟正黑體"/>
               </a:rPr>
               <a:t>。德銀直言油價是這輪行情的「總開關」：基準情境假設霍爾木茲海峽於 6 月底重啟、布倫特二季均價約 109 美元、四季回落至 </a:t>
             </a:r>
@@ -7281,6 +7623,9 @@
                 <a:solidFill>
                   <a:srgbClr val="222222"/>
                 </a:solidFill>
+                <a:latin typeface="微軟正黑體"/>
+                <a:ea typeface="微軟正黑體"/>
+                <a:cs typeface="微軟正黑體"/>
               </a:rPr>
               <a:t>86 美元</a:t>
             </a:r>
@@ -7289,6 +7634,9 @@
                 <a:solidFill>
                   <a:srgbClr val="222222"/>
                 </a:solidFill>
+                <a:latin typeface="微軟正黑體"/>
+                <a:ea typeface="微軟正黑體"/>
+                <a:cs typeface="微軟正黑體"/>
               </a:rPr>
               <a:t>；但若海峽封鎖拖延，油價恐逼近 </a:t>
             </a:r>
@@ -7297,6 +7645,9 @@
                 <a:solidFill>
                   <a:srgbClr val="222222"/>
                 </a:solidFill>
+                <a:latin typeface="微軟正黑體"/>
+                <a:ea typeface="微軟正黑體"/>
+                <a:cs typeface="微軟正黑體"/>
               </a:rPr>
               <a:t>150 美元</a:t>
             </a:r>
@@ -7305,6 +7656,9 @@
                 <a:solidFill>
                   <a:srgbClr val="222222"/>
                 </a:solidFill>
+                <a:latin typeface="微軟正黑體"/>
+                <a:ea typeface="微軟正黑體"/>
+                <a:cs typeface="微軟正黑體"/>
               </a:rPr>
               <a:t>，屆時全球增長風險將非線性放大，歐洲最先承壓。</a:t>
             </a:r>
@@ -7313,6 +7667,9 @@
                 <a:solidFill>
                   <a:srgbClr val="222222"/>
                 </a:solidFill>
+                <a:latin typeface="微軟正黑體"/>
+                <a:ea typeface="微軟正黑體"/>
+                <a:cs typeface="微軟正黑體"/>
               </a:rPr>
               <a:t>6/16</a:t>
             </a:r>
@@ -7321,6 +7678,9 @@
                 <a:solidFill>
                   <a:srgbClr val="222222"/>
                 </a:solidFill>
+                <a:latin typeface="微軟正黑體"/>
+                <a:ea typeface="微軟正黑體"/>
+                <a:cs typeface="微軟正黑體"/>
               </a:rPr>
               <a:t> 的美伊臨時協議使布倫特一度跌破 84 美元，但彭博提醒協議持久性偏低、海峽重啟仍脆弱。</a:t>
             </a:r>
@@ -7339,6 +7699,9 @@
                 <a:solidFill>
                   <a:srgbClr val="222222"/>
                 </a:solidFill>
+                <a:latin typeface="微軟正黑體"/>
+                <a:ea typeface="微軟正黑體"/>
+                <a:cs typeface="微軟正黑體"/>
               </a:rPr>
               <a:t>利率方面，高盛劃出明確紅線：</a:t>
             </a:r>
@@ -7347,6 +7710,9 @@
                 <a:solidFill>
                   <a:srgbClr val="222222"/>
                 </a:solidFill>
+                <a:latin typeface="微軟正黑體"/>
+                <a:ea typeface="微軟正黑體"/>
+                <a:cs typeface="微軟正黑體"/>
               </a:rPr>
               <a:t>10 年期美債殖利率觸及 5%</a:t>
             </a:r>
@@ -7355,6 +7721,9 @@
                 <a:solidFill>
                   <a:srgbClr val="222222"/>
                 </a:solidFill>
+                <a:latin typeface="微軟正黑體"/>
+                <a:ea typeface="微軟正黑體"/>
+                <a:cs typeface="微軟正黑體"/>
               </a:rPr>
               <a:t>，才是真正威脅股市估值的水準——目前尚未觸及，但債市已成為下半年最關鍵的變數。財政赤字接近 GDP 的 </a:t>
             </a:r>
@@ -7363,6 +7732,9 @@
                 <a:solidFill>
                   <a:srgbClr val="222222"/>
                 </a:solidFill>
+                <a:latin typeface="微軟正黑體"/>
+                <a:ea typeface="微軟正黑體"/>
+                <a:cs typeface="微軟正黑體"/>
               </a:rPr>
               <a:t>6.6%</a:t>
             </a:r>
@@ -7371,6 +7743,9 @@
                 <a:solidFill>
                   <a:srgbClr val="222222"/>
                 </a:solidFill>
+                <a:latin typeface="微軟正黑體"/>
+                <a:ea typeface="微軟正黑體"/>
+                <a:cs typeface="微軟正黑體"/>
               </a:rPr>
               <a:t>、長債供給增加、通膨回落放緩，使長端利率面臨上行壓力，殖利率曲線呈現「熊市平坦化」。真正的風險不在於 AI 故事結束，而在於</a:t>
             </a:r>
@@ -7379,6 +7754,9 @@
                 <a:solidFill>
                   <a:srgbClr val="222222"/>
                 </a:solidFill>
+                <a:latin typeface="微軟正黑體"/>
+                <a:ea typeface="微軟正黑體"/>
+                <a:cs typeface="微軟正黑體"/>
               </a:rPr>
               <a:t>利率、槓桿與波動率開始相互放大</a:t>
             </a:r>
@@ -7387,6 +7765,9 @@
                 <a:solidFill>
                   <a:srgbClr val="222222"/>
                 </a:solidFill>
+                <a:latin typeface="微軟正黑體"/>
+                <a:ea typeface="微軟正黑體"/>
+                <a:cs typeface="微軟正黑體"/>
               </a:rPr>
               <a:t>。</a:t>
             </a:r>
@@ -7405,6 +7786,9 @@
                 <a:solidFill>
                   <a:srgbClr val="222222"/>
                 </a:solidFill>
+                <a:latin typeface="微軟正黑體"/>
+                <a:ea typeface="微軟正黑體"/>
+                <a:cs typeface="微軟正黑體"/>
               </a:rPr>
               <a:t>兩者交匯出全場的勝負手——</a:t>
             </a:r>
@@ -7413,6 +7797,9 @@
                 <a:solidFill>
                   <a:srgbClr val="222222"/>
                 </a:solidFill>
+                <a:latin typeface="微軟正黑體"/>
+                <a:ea typeface="微軟正黑體"/>
+                <a:cs typeface="微軟正黑體"/>
               </a:rPr>
               <a:t>油價能否回落到足以把 CPI 壓回 3% 以下</a:t>
             </a:r>
@@ -7421,6 +7808,9 @@
                 <a:solidFill>
                   <a:srgbClr val="222222"/>
                 </a:solidFill>
+                <a:latin typeface="微軟正黑體"/>
+                <a:ea typeface="微軟正黑體"/>
+                <a:cs typeface="微軟正黑體"/>
               </a:rPr>
               <a:t>。若能，則花旗的降息劇本成立；若不能，則美銀所警告的「滯脹」路徑風險上升。</a:t>
             </a:r>
@@ -7594,6 +7984,9 @@
                 <a:solidFill>
                   <a:srgbClr val="FFFFFF"/>
                 </a:solidFill>
+                <a:latin typeface="微軟正黑體"/>
+                <a:ea typeface="微軟正黑體"/>
+                <a:cs typeface="微軟正黑體"/>
               </a:rPr>
               <a:t>油價情境（布倫特，美元/桶）</a:t>
             </a:r>
@@ -7635,6 +8028,9 @@
                 <a:solidFill>
                   <a:srgbClr val="222222"/>
                 </a:solidFill>
+                <a:latin typeface="微軟正黑體"/>
+                <a:ea typeface="微軟正黑體"/>
+                <a:cs typeface="微軟正黑體"/>
               </a:rPr>
               <a:t>· 基準 86　|　事故情境 150</a:t>
             </a:r>
@@ -7653,6 +8049,9 @@
                 <a:solidFill>
                   <a:srgbClr val="222222"/>
                 </a:solidFill>
+                <a:latin typeface="微軟正黑體"/>
+                <a:ea typeface="微軟正黑體"/>
+                <a:cs typeface="微軟正黑體"/>
               </a:rPr>
               <a:t>· 6/16 臨時協議後一度跌破 84</a:t>
             </a:r>
@@ -7826,6 +8225,9 @@
                 <a:solidFill>
                   <a:srgbClr val="FFFFFF"/>
                 </a:solidFill>
+                <a:latin typeface="微軟正黑體"/>
+                <a:ea typeface="微軟正黑體"/>
+                <a:cs typeface="微軟正黑體"/>
               </a:rPr>
               <a:t>利率紅線</a:t>
             </a:r>
@@ -7867,6 +8269,9 @@
                 <a:solidFill>
                   <a:srgbClr val="222222"/>
                 </a:solidFill>
+                <a:latin typeface="微軟正黑體"/>
+                <a:ea typeface="微軟正黑體"/>
+                <a:cs typeface="微軟正黑體"/>
               </a:rPr>
               <a:t>· 10 年期美債 5% ＝股市紅線</a:t>
             </a:r>
@@ -7885,6 +8290,9 @@
                 <a:solidFill>
                   <a:srgbClr val="222222"/>
                 </a:solidFill>
+                <a:latin typeface="微軟正黑體"/>
+                <a:ea typeface="微軟正黑體"/>
+                <a:cs typeface="微軟正黑體"/>
               </a:rPr>
               <a:t>· 財政赤字 ≈ GDP 6.6%，曲線熊平</a:t>
             </a:r>
@@ -8058,6 +8466,9 @@
                 <a:solidFill>
                   <a:srgbClr val="FFFFFF"/>
                 </a:solidFill>
+                <a:latin typeface="微軟正黑體"/>
+                <a:ea typeface="微軟正黑體"/>
+                <a:cs typeface="微軟正黑體"/>
               </a:rPr>
               <a:t>全場勝負手</a:t>
             </a:r>
@@ -8099,6 +8510,9 @@
                 <a:solidFill>
                   <a:srgbClr val="222222"/>
                 </a:solidFill>
+                <a:latin typeface="微軟正黑體"/>
+                <a:ea typeface="微軟正黑體"/>
+                <a:cs typeface="微軟正黑體"/>
               </a:rPr>
               <a:t>· 油價能否壓 CPI 回 3% 以下</a:t>
             </a:r>
@@ -8117,6 +8531,9 @@
                 <a:solidFill>
                   <a:srgbClr val="222222"/>
                 </a:solidFill>
+                <a:latin typeface="微軟正黑體"/>
+                <a:ea typeface="微軟正黑體"/>
+                <a:cs typeface="微軟正黑體"/>
               </a:rPr>
               <a:t>· → 花旗降息 vs 美銀滯脹</a:t>
             </a:r>
@@ -8158,6 +8575,9 @@
                 <a:solidFill>
                   <a:srgbClr val="6A7C8D"/>
                 </a:solidFill>
+                <a:latin typeface="微軟正黑體"/>
+                <a:ea typeface="微軟正黑體"/>
+                <a:cs typeface="微軟正黑體"/>
               </a:rPr>
               <a:t>資料來源：Deutsche Bank / Goldman Sachs / Citi / BofA / Bloomberg（PA 晨會摘要 2026/06）</a:t>
             </a:r>
@@ -8202,6 +8622,9 @@
                 <a:solidFill>
                   <a:srgbClr val="222222"/>
                 </a:solidFill>
+                <a:latin typeface="微軟正黑體"/>
+                <a:ea typeface="微軟正黑體"/>
+                <a:cs typeface="微軟正黑體"/>
               </a:rPr>
               <a:t>區域分化與市場溫度</a:t>
             </a:r>
@@ -8287,6 +8710,9 @@
                 <a:solidFill>
                   <a:srgbClr val="222222"/>
                 </a:solidFill>
+                <a:latin typeface="微軟正黑體"/>
+                <a:ea typeface="微軟正黑體"/>
+                <a:cs typeface="微軟正黑體"/>
               </a:rPr>
               <a:t>在共同的宏觀背景下，各區域表現明顯分化：</a:t>
             </a:r>
@@ -8295,6 +8721,9 @@
                 <a:solidFill>
                   <a:srgbClr val="222222"/>
                 </a:solidFill>
+                <a:latin typeface="微軟正黑體"/>
+                <a:ea typeface="微軟正黑體"/>
+                <a:cs typeface="微軟正黑體"/>
               </a:rPr>
               <a:t>美國</a:t>
             </a:r>
@@ -8303,6 +8732,9 @@
                 <a:solidFill>
                   <a:srgbClr val="222222"/>
                 </a:solidFill>
+                <a:latin typeface="微軟正黑體"/>
+                <a:ea typeface="微軟正黑體"/>
+                <a:cs typeface="微軟正黑體"/>
               </a:rPr>
               <a:t>最具韌性、是各大投行一致的超配市場，隱憂在估值與擁擠；</a:t>
             </a:r>
@@ -8311,6 +8743,9 @@
                 <a:solidFill>
                   <a:srgbClr val="222222"/>
                 </a:solidFill>
+                <a:latin typeface="微軟正黑體"/>
+                <a:ea typeface="微軟正黑體"/>
+                <a:cs typeface="微軟正黑體"/>
               </a:rPr>
               <a:t>歐洲</a:t>
             </a:r>
@@ -8319,6 +8754,9 @@
                 <a:solidFill>
                   <a:srgbClr val="222222"/>
                 </a:solidFill>
+                <a:latin typeface="微軟正黑體"/>
+                <a:ea typeface="微軟正黑體"/>
+                <a:cs typeface="微軟正黑體"/>
               </a:rPr>
               <a:t>最為脆弱，距技術性衰退僅一步之遙；</a:t>
             </a:r>
@@ -8327,6 +8765,9 @@
                 <a:solidFill>
                   <a:srgbClr val="222222"/>
                 </a:solidFill>
+                <a:latin typeface="微軟正黑體"/>
+                <a:ea typeface="微軟正黑體"/>
+                <a:cs typeface="微軟正黑體"/>
               </a:rPr>
               <a:t>亞洲（除日）</a:t>
             </a:r>
@@ -8335,6 +8776,9 @@
                 <a:solidFill>
                   <a:srgbClr val="222222"/>
                 </a:solidFill>
+                <a:latin typeface="微軟正黑體"/>
+                <a:ea typeface="微軟正黑體"/>
+                <a:cs typeface="微軟正黑體"/>
               </a:rPr>
               <a:t>為亮點，</a:t>
             </a:r>
@@ -8343,6 +8787,9 @@
                 <a:solidFill>
                   <a:srgbClr val="222222"/>
                 </a:solidFill>
+                <a:latin typeface="微軟正黑體"/>
+                <a:ea typeface="微軟正黑體"/>
+                <a:cs typeface="微軟正黑體"/>
               </a:rPr>
               <a:t>韓國</a:t>
             </a:r>
@@ -8351,6 +8798,9 @@
                 <a:solidFill>
                   <a:srgbClr val="222222"/>
                 </a:solidFill>
+                <a:latin typeface="微軟正黑體"/>
+                <a:ea typeface="微軟正黑體"/>
+                <a:cs typeface="微軟正黑體"/>
               </a:rPr>
               <a:t>受惠記憶體晶片超級週期、估值仍低，存在重估空間；</a:t>
             </a:r>
@@ -8359,6 +8809,9 @@
                 <a:solidFill>
                   <a:srgbClr val="222222"/>
                 </a:solidFill>
+                <a:latin typeface="微軟正黑體"/>
+                <a:ea typeface="微軟正黑體"/>
+                <a:cs typeface="微軟正黑體"/>
               </a:rPr>
               <a:t>日本</a:t>
             </a:r>
@@ -8367,6 +8820,9 @@
                 <a:solidFill>
                   <a:srgbClr val="222222"/>
                 </a:solidFill>
+                <a:latin typeface="微軟正黑體"/>
+                <a:ea typeface="微軟正黑體"/>
+                <a:cs typeface="微軟正黑體"/>
               </a:rPr>
               <a:t>被油價改寫、日圓走貶；</a:t>
             </a:r>
@@ -8375,6 +8831,9 @@
                 <a:solidFill>
                   <a:srgbClr val="222222"/>
                 </a:solidFill>
+                <a:latin typeface="微軟正黑體"/>
+                <a:ea typeface="微軟正黑體"/>
+                <a:cs typeface="微軟正黑體"/>
               </a:rPr>
               <a:t>中國</a:t>
             </a:r>
@@ -8383,6 +8842,9 @@
                 <a:solidFill>
                   <a:srgbClr val="222222"/>
                 </a:solidFill>
+                <a:latin typeface="微軟正黑體"/>
+                <a:ea typeface="微軟正黑體"/>
+                <a:cs typeface="微軟正黑體"/>
               </a:rPr>
               <a:t>資金面偏弱。與此同時，支撐行情的情緒與資金本身已成風險——擁擠度與樂觀程度雙雙逼近極端。</a:t>
             </a:r>
@@ -8428,6 +8890,9 @@
                           <a:solidFill>
                             <a:srgbClr val="FFFFFF"/>
                           </a:solidFill>
+                          <a:latin typeface="微軟正黑體"/>
+                          <a:ea typeface="微軟正黑體"/>
+                          <a:cs typeface="微軟正黑體"/>
                         </a:rPr>
                         <a:t>區域</a:t>
                       </a:r>
@@ -8454,6 +8919,9 @@
                           <a:solidFill>
                             <a:srgbClr val="FFFFFF"/>
                           </a:solidFill>
+                          <a:latin typeface="微軟正黑體"/>
+                          <a:ea typeface="微軟正黑體"/>
+                          <a:cs typeface="微軟正黑體"/>
                         </a:rPr>
                         <a:t>觀點</a:t>
                       </a:r>
@@ -8480,6 +8948,9 @@
                           <a:solidFill>
                             <a:srgbClr val="FFFFFF"/>
                           </a:solidFill>
+                          <a:latin typeface="微軟正黑體"/>
+                          <a:ea typeface="微軟正黑體"/>
+                          <a:cs typeface="微軟正黑體"/>
                         </a:rPr>
                         <a:t>關鍵數據</a:t>
                       </a:r>
@@ -8508,6 +8979,9 @@
                           <a:solidFill>
                             <a:srgbClr val="222222"/>
                           </a:solidFill>
+                          <a:latin typeface="微軟正黑體"/>
+                          <a:ea typeface="微軟正黑體"/>
+                          <a:cs typeface="微軟正黑體"/>
                         </a:rPr>
                         <a:t>美國</a:t>
                       </a:r>
@@ -8534,6 +9008,9 @@
                           <a:solidFill>
                             <a:srgbClr val="222222"/>
                           </a:solidFill>
+                          <a:latin typeface="微軟正黑體"/>
+                          <a:ea typeface="微軟正黑體"/>
+                          <a:cs typeface="微軟正黑體"/>
                         </a:rPr>
                         <a:t>最具韌性，一致超配</a:t>
                       </a:r>
@@ -8560,6 +9037,9 @@
                           <a:solidFill>
                             <a:srgbClr val="222222"/>
                           </a:solidFill>
+                          <a:latin typeface="微軟正黑體"/>
+                          <a:ea typeface="微軟正黑體"/>
+                          <a:cs typeface="微軟正黑體"/>
                         </a:rPr>
                         <a:t>消費+設備投資；估值偏高</a:t>
                       </a:r>
@@ -8588,6 +9068,9 @@
                           <a:solidFill>
                             <a:srgbClr val="222222"/>
                           </a:solidFill>
+                          <a:latin typeface="微軟正黑體"/>
+                          <a:ea typeface="微軟正黑體"/>
+                          <a:cs typeface="微軟正黑體"/>
                         </a:rPr>
                         <a:t>亞洲(除日)</a:t>
                       </a:r>
@@ -8614,6 +9097,9 @@
                           <a:solidFill>
                             <a:srgbClr val="222222"/>
                           </a:solidFill>
+                          <a:latin typeface="微軟正黑體"/>
+                          <a:ea typeface="微軟正黑體"/>
+                          <a:cs typeface="微軟正黑體"/>
                         </a:rPr>
                         <a:t>亮點，韓國突圍</a:t>
                       </a:r>
@@ -8640,6 +9126,9 @@
                           <a:solidFill>
                             <a:srgbClr val="222222"/>
                           </a:solidFill>
+                          <a:latin typeface="微軟正黑體"/>
+                          <a:ea typeface="微軟正黑體"/>
+                          <a:cs typeface="微軟正黑體"/>
                         </a:rPr>
                         <a:t>MSCI 韓股 7.2x；IT EPS 翻倍</a:t>
                       </a:r>
@@ -8668,6 +9157,9 @@
                           <a:solidFill>
                             <a:srgbClr val="222222"/>
                           </a:solidFill>
+                          <a:latin typeface="微軟正黑體"/>
+                          <a:ea typeface="微軟正黑體"/>
+                          <a:cs typeface="微軟正黑體"/>
                         </a:rPr>
                         <a:t>日本</a:t>
                       </a:r>
@@ -8694,6 +9186,9 @@
                           <a:solidFill>
                             <a:srgbClr val="222222"/>
                           </a:solidFill>
+                          <a:latin typeface="微軟正黑體"/>
+                          <a:ea typeface="微軟正黑體"/>
+                          <a:cs typeface="微軟正黑體"/>
                         </a:rPr>
                         <a:t>被油價改寫</a:t>
                       </a:r>
@@ -8720,6 +9215,9 @@
                           <a:solidFill>
                             <a:srgbClr val="222222"/>
                           </a:solidFill>
+                          <a:latin typeface="微軟正黑體"/>
+                          <a:ea typeface="微軟正黑體"/>
+                          <a:cs typeface="微軟正黑體"/>
                         </a:rPr>
                         <a:t>日圓 161.8（24/7 來最低）</a:t>
                       </a:r>
@@ -8748,6 +9246,9 @@
                           <a:solidFill>
                             <a:srgbClr val="222222"/>
                           </a:solidFill>
+                          <a:latin typeface="微軟正黑體"/>
+                          <a:ea typeface="微軟正黑體"/>
+                          <a:cs typeface="微軟正黑體"/>
                         </a:rPr>
                         <a:t>歐洲</a:t>
                       </a:r>
@@ -8774,6 +9275,9 @@
                           <a:solidFill>
                             <a:srgbClr val="222222"/>
                           </a:solidFill>
+                          <a:latin typeface="微軟正黑體"/>
+                          <a:ea typeface="微軟正黑體"/>
+                          <a:cs typeface="微軟正黑體"/>
                         </a:rPr>
                         <a:t>最弱</a:t>
                       </a:r>
@@ -8800,6 +9304,9 @@
                           <a:solidFill>
                             <a:srgbClr val="222222"/>
                           </a:solidFill>
+                          <a:latin typeface="微軟正黑體"/>
+                          <a:ea typeface="微軟正黑體"/>
+                          <a:cs typeface="微軟正黑體"/>
                         </a:rPr>
                         <a:t>2026 GDP 0.5%；近技術性衰退</a:t>
                       </a:r>
@@ -8828,6 +9335,9 @@
                           <a:solidFill>
                             <a:srgbClr val="222222"/>
                           </a:solidFill>
+                          <a:latin typeface="微軟正黑體"/>
+                          <a:ea typeface="微軟正黑體"/>
+                          <a:cs typeface="微軟正黑體"/>
                         </a:rPr>
                         <a:t>中國</a:t>
                       </a:r>
@@ -8854,6 +9364,9 @@
                           <a:solidFill>
                             <a:srgbClr val="222222"/>
                           </a:solidFill>
+                          <a:latin typeface="微軟正黑體"/>
+                          <a:ea typeface="微軟正黑體"/>
+                          <a:cs typeface="微軟正黑體"/>
                         </a:rPr>
                         <a:t>資金偏弱</a:t>
                       </a:r>
@@ -8880,6 +9393,9 @@
                           <a:solidFill>
                             <a:srgbClr val="222222"/>
                           </a:solidFill>
+                          <a:latin typeface="微軟正黑體"/>
+                          <a:ea typeface="微軟正黑體"/>
+                          <a:cs typeface="微軟正黑體"/>
                         </a:rPr>
                         <a:t>連 11 週淨流出</a:t>
                       </a:r>
@@ -9019,6 +9535,9 @@
                 <a:solidFill>
                   <a:srgbClr val="977B3B"/>
                 </a:solidFill>
+                <a:latin typeface="微軟正黑體"/>
+                <a:ea typeface="微軟正黑體"/>
+                <a:cs typeface="微軟正黑體"/>
               </a:rPr>
               <a:t>39%</a:t>
             </a:r>
@@ -9060,6 +9579,9 @@
                 <a:solidFill>
                   <a:srgbClr val="222222"/>
                 </a:solidFill>
+                <a:latin typeface="微軟正黑體"/>
+                <a:ea typeface="微軟正黑體"/>
+                <a:cs typeface="微軟正黑體"/>
               </a:rPr>
               <a:t>AI 股佔標普權重</a:t>
             </a:r>
@@ -9189,6 +9711,9 @@
                 <a:solidFill>
                   <a:srgbClr val="B14A42"/>
                 </a:solidFill>
+                <a:latin typeface="微軟正黑體"/>
+                <a:ea typeface="微軟正黑體"/>
+                <a:cs typeface="微軟正黑體"/>
               </a:rPr>
               <a:t>80%</a:t>
             </a:r>
@@ -9230,6 +9755,9 @@
                 <a:solidFill>
                   <a:srgbClr val="222222"/>
                 </a:solidFill>
+                <a:latin typeface="微軟正黑體"/>
+                <a:ea typeface="微軟正黑體"/>
+                <a:cs typeface="微軟正黑體"/>
               </a:rPr>
               <a:t>做多半導體＝史上最擁擠</a:t>
             </a:r>
@@ -9359,6 +9887,9 @@
                 <a:solidFill>
                   <a:srgbClr val="B14A42"/>
                 </a:solidFill>
+                <a:latin typeface="微軟正黑體"/>
+                <a:ea typeface="微軟正黑體"/>
+                <a:cs typeface="微軟正黑體"/>
               </a:rPr>
               <a:t>9.2</a:t>
             </a:r>
@@ -9400,6 +9931,9 @@
                 <a:solidFill>
                   <a:srgbClr val="222222"/>
                 </a:solidFill>
+                <a:latin typeface="微軟正黑體"/>
+                <a:ea typeface="微軟正黑體"/>
+                <a:cs typeface="微軟正黑體"/>
               </a:rPr>
               <a:t>美銀牛熊指標（賣出區）</a:t>
             </a:r>
@@ -9529,6 +10063,9 @@
                 <a:solidFill>
                   <a:srgbClr val="235173"/>
                 </a:solidFill>
+                <a:latin typeface="微軟正黑體"/>
+                <a:ea typeface="微軟正黑體"/>
+                <a:cs typeface="微軟正黑體"/>
               </a:rPr>
               <a:t>4.1%</a:t>
             </a:r>
@@ -9570,6 +10107,9 @@
                 <a:solidFill>
                   <a:srgbClr val="222222"/>
                 </a:solidFill>
+                <a:latin typeface="微軟正黑體"/>
+                <a:ea typeface="微軟正黑體"/>
+                <a:cs typeface="微軟正黑體"/>
               </a:rPr>
               <a:t>平均現金水位（防禦↑）</a:t>
             </a:r>
@@ -9699,6 +10239,9 @@
                 <a:solidFill>
                   <a:srgbClr val="977B3B"/>
                 </a:solidFill>
+                <a:latin typeface="微軟正黑體"/>
+                <a:ea typeface="微軟正黑體"/>
+                <a:cs typeface="微軟正黑體"/>
               </a:rPr>
               <a:t>$119bn</a:t>
             </a:r>
@@ -9740,6 +10283,9 @@
                 <a:solidFill>
                   <a:srgbClr val="222222"/>
                 </a:solidFill>
+                <a:latin typeface="微軟正黑體"/>
+                <a:ea typeface="微軟正黑體"/>
+                <a:cs typeface="微軟正黑體"/>
               </a:rPr>
               <a:t>美股單週淨流入（紀錄）</a:t>
             </a:r>
@@ -9869,6 +10415,9 @@
                 <a:solidFill>
                   <a:srgbClr val="235173"/>
                 </a:solidFill>
+                <a:latin typeface="微軟正黑體"/>
+                <a:ea typeface="微軟正黑體"/>
+                <a:cs typeface="微軟正黑體"/>
               </a:rPr>
               <a:t>28%</a:t>
             </a:r>
@@ -9910,6 +10459,9 @@
                 <a:solidFill>
                   <a:srgbClr val="222222"/>
                 </a:solidFill>
+                <a:latin typeface="微軟正黑體"/>
+                <a:ea typeface="微軟正黑體"/>
+                <a:cs typeface="微軟正黑體"/>
               </a:rPr>
               <a:t>視 AI 泡沫為首要尾部風險</a:t>
             </a:r>
@@ -9951,6 +10503,9 @@
                 <a:solidFill>
                   <a:srgbClr val="6A7C8D"/>
                 </a:solidFill>
+                <a:latin typeface="微軟正黑體"/>
+                <a:ea typeface="微軟正黑體"/>
+                <a:cs typeface="微軟正黑體"/>
               </a:rPr>
               <a:t>資料來源：Deutsche Bank / Morgan Stanley / BofA / Bloomberg（PA 晨會摘要 2026/06）</a:t>
             </a:r>
@@ -9995,6 +10550,9 @@
                 <a:solidFill>
                   <a:srgbClr val="222222"/>
                 </a:solidFill>
+                <a:latin typeface="微軟正黑體"/>
+                <a:ea typeface="微軟正黑體"/>
+                <a:cs typeface="微軟正黑體"/>
               </a:rPr>
               <a:t>結論與資產配置建議</a:t>
             </a:r>
@@ -10080,6 +10638,9 @@
                 <a:solidFill>
                   <a:srgbClr val="222222"/>
                 </a:solidFill>
+                <a:latin typeface="微軟正黑體"/>
+                <a:ea typeface="微軟正黑體"/>
+                <a:cs typeface="微軟正黑體"/>
               </a:rPr>
               <a:t>綜合過去四週各大投行觀點，我們維持</a:t>
             </a:r>
@@ -10088,6 +10649,9 @@
                 <a:solidFill>
                   <a:srgbClr val="222222"/>
                 </a:solidFill>
+                <a:latin typeface="微軟正黑體"/>
+                <a:ea typeface="微軟正黑體"/>
+                <a:cs typeface="微軟正黑體"/>
               </a:rPr>
               <a:t>「建設性、但防禦微調」</a:t>
             </a:r>
@@ -10096,6 +10660,9 @@
                 <a:solidFill>
                   <a:srgbClr val="222222"/>
                 </a:solidFill>
+                <a:latin typeface="微軟正黑體"/>
+                <a:ea typeface="微軟正黑體"/>
+                <a:cs typeface="微軟正黑體"/>
               </a:rPr>
               <a:t>的基調：基本面（盈餘）仍足以支撐市場，但在擁擠度創高、利率逼近紅線的環境下，應主動</a:t>
             </a:r>
@@ -10104,6 +10671,9 @@
                 <a:solidFill>
                   <a:srgbClr val="222222"/>
                 </a:solidFill>
+                <a:latin typeface="微軟正黑體"/>
+                <a:ea typeface="微軟正黑體"/>
+                <a:cs typeface="微軟正黑體"/>
               </a:rPr>
               <a:t>降低集中與槓桿、提高現金緩衝</a:t>
             </a:r>
@@ -10112,6 +10682,9 @@
                 <a:solidFill>
                   <a:srgbClr val="222222"/>
                 </a:solidFill>
+                <a:latin typeface="微軟正黑體"/>
+                <a:ea typeface="微軟正黑體"/>
+                <a:cs typeface="微軟正黑體"/>
               </a:rPr>
               <a:t>，並緊盯油價與利率兩大搖擺因子。具體配置上：</a:t>
             </a:r>
@@ -10285,6 +10858,9 @@
                 <a:solidFill>
                   <a:srgbClr val="FFFFFF"/>
                 </a:solidFill>
+                <a:latin typeface="微軟正黑體"/>
+                <a:ea typeface="微軟正黑體"/>
+                <a:cs typeface="微軟正黑體"/>
               </a:rPr>
               <a:t>▲  增持 OVERWEIGHT</a:t>
             </a:r>
@@ -10326,6 +10902,9 @@
                 <a:solidFill>
                   <a:srgbClr val="222222"/>
                 </a:solidFill>
+                <a:latin typeface="微軟正黑體"/>
+                <a:ea typeface="微軟正黑體"/>
+                <a:cs typeface="微軟正黑體"/>
               </a:rPr>
               <a:t>· 美股（品質/盈餘）：金融・工業・醫療，廣度外擴</a:t>
             </a:r>
@@ -10344,6 +10923,9 @@
                 <a:solidFill>
                   <a:srgbClr val="222222"/>
                 </a:solidFill>
+                <a:latin typeface="微軟正黑體"/>
+                <a:ea typeface="微軟正黑體"/>
+                <a:cs typeface="微軟正黑體"/>
               </a:rPr>
               <a:t>· 亞洲（除日）/ 韓國：晶片週期 + 低估值重估</a:t>
             </a:r>
@@ -10362,6 +10944,9 @@
                 <a:solidFill>
                   <a:srgbClr val="222222"/>
                 </a:solidFill>
+                <a:latin typeface="微軟正黑體"/>
+                <a:ea typeface="微軟正黑體"/>
+                <a:cs typeface="微軟正黑體"/>
               </a:rPr>
               <a:t>· 中期美債：殖利率年底回落，carry + 防禦</a:t>
             </a:r>
@@ -10380,6 +10965,9 @@
                 <a:solidFill>
                   <a:srgbClr val="222222"/>
                 </a:solidFill>
+                <a:latin typeface="微軟正黑體"/>
+                <a:ea typeface="微軟正黑體"/>
+                <a:cs typeface="微軟正黑體"/>
               </a:rPr>
               <a:t>· 新興市場低波動、高股息個股</a:t>
             </a:r>
@@ -10553,6 +11141,9 @@
                 <a:solidFill>
                   <a:srgbClr val="FFFFFF"/>
                 </a:solidFill>
+                <a:latin typeface="微軟正黑體"/>
+                <a:ea typeface="微軟正黑體"/>
+                <a:cs typeface="微軟正黑體"/>
               </a:rPr>
               <a:t>▼  減持 UNDERWEIGHT</a:t>
             </a:r>
@@ -10594,6 +11185,9 @@
                 <a:solidFill>
                   <a:srgbClr val="222222"/>
                 </a:solidFill>
+                <a:latin typeface="微軟正黑體"/>
+                <a:ea typeface="微軟正黑體"/>
+                <a:cs typeface="微軟正黑體"/>
               </a:rPr>
               <a:t>· 擁擠的大型科技 / 半導體集中部位（降槓桿）</a:t>
             </a:r>
@@ -10612,6 +11206,9 @@
                 <a:solidFill>
                   <a:srgbClr val="222222"/>
                 </a:solidFill>
+                <a:latin typeface="微軟正黑體"/>
+                <a:ea typeface="微軟正黑體"/>
+                <a:cs typeface="微軟正黑體"/>
               </a:rPr>
               <a:t>· 長天期債券：熊陡風險，10Y 逼近 5%</a:t>
             </a:r>
@@ -10630,6 +11227,9 @@
                 <a:solidFill>
                   <a:srgbClr val="222222"/>
                 </a:solidFill>
+                <a:latin typeface="微軟正黑體"/>
+                <a:ea typeface="微軟正黑體"/>
+                <a:cs typeface="微軟正黑體"/>
               </a:rPr>
               <a:t>· 歐洲股票 / 信用：近技術性衰退</a:t>
             </a:r>
@@ -10648,6 +11248,9 @@
                 <a:solidFill>
                   <a:srgbClr val="222222"/>
                 </a:solidFill>
+                <a:latin typeface="微軟正黑體"/>
+                <a:ea typeface="微軟正黑體"/>
+                <a:cs typeface="微軟正黑體"/>
               </a:rPr>
               <a:t>· 日圓 / 未對沖日股：結構性走弱</a:t>
             </a:r>
@@ -10821,6 +11424,9 @@
                 <a:solidFill>
                   <a:srgbClr val="FFFFFF"/>
                 </a:solidFill>
+                <a:latin typeface="微軟正黑體"/>
+                <a:ea typeface="微軟正黑體"/>
+                <a:cs typeface="微軟正黑體"/>
               </a:rPr>
               <a:t>●  中性 / 戰術 NEUTRAL</a:t>
             </a:r>
@@ -10862,6 +11468,9 @@
                 <a:solidFill>
                   <a:srgbClr val="222222"/>
                 </a:solidFill>
+                <a:latin typeface="微軟正黑體"/>
+                <a:ea typeface="微軟正黑體"/>
+                <a:cs typeface="微軟正黑體"/>
               </a:rPr>
               <a:t>· 歐洲能源股：Hormuz 重啟 → 降至中性</a:t>
             </a:r>
@@ -10880,6 +11489,9 @@
                 <a:solidFill>
                   <a:srgbClr val="222222"/>
                 </a:solidFill>
+                <a:latin typeface="微軟正黑體"/>
+                <a:ea typeface="微軟正黑體"/>
+                <a:cs typeface="微軟正黑體"/>
               </a:rPr>
               <a:t>· 黃金：滯脹 / 地緣對沖，小幅配置</a:t>
             </a:r>
@@ -10898,6 +11510,9 @@
                 <a:solidFill>
                   <a:srgbClr val="222222"/>
                 </a:solidFill>
+                <a:latin typeface="微軟正黑體"/>
+                <a:ea typeface="微軟正黑體"/>
+                <a:cs typeface="微軟正黑體"/>
               </a:rPr>
               <a:t>· 現金：提高至 ~4%，保留乾火藥</a:t>
             </a:r>
@@ -10916,6 +11531,9 @@
                 <a:solidFill>
                   <a:srgbClr val="222222"/>
                 </a:solidFill>
+                <a:latin typeface="微軟正黑體"/>
+                <a:ea typeface="微軟正黑體"/>
+                <a:cs typeface="微軟正黑體"/>
               </a:rPr>
               <a:t>· 波動率資產：適度配置以防尾部</a:t>
             </a:r>
@@ -10957,6 +11575,9 @@
                 <a:solidFill>
                   <a:srgbClr val="6A7C8D"/>
                 </a:solidFill>
+                <a:latin typeface="微軟正黑體"/>
+                <a:ea typeface="微軟正黑體"/>
+                <a:cs typeface="微軟正黑體"/>
               </a:rPr>
               <a:t>※ 上述為彙整各投行研究之整合視角，非個別投資建議；花旗 / 大摩對聯儲路徑（仍見降息）與多數機構（轉向加息）存在分歧，請依自身風險屬性判讀。</a:t>
             </a:r>
@@ -11001,6 +11622,9 @@
                 <a:solidFill>
                   <a:srgbClr val="222222"/>
                 </a:solidFill>
+                <a:latin typeface="微軟正黑體"/>
+                <a:ea typeface="微軟正黑體"/>
+                <a:cs typeface="微軟正黑體"/>
               </a:rPr>
               <a:t>下一步：關鍵觀察點與風險地圖</a:t>
             </a:r>
@@ -11086,6 +11710,9 @@
                 <a:solidFill>
                   <a:srgbClr val="222222"/>
                 </a:solidFill>
+                <a:latin typeface="微軟正黑體"/>
+                <a:ea typeface="微軟正黑體"/>
+                <a:cs typeface="微軟正黑體"/>
               </a:rPr>
               <a:t>未來數週，市場走向「1996 軟著陸」或「1999 過熱」劇本，取決於以下六個變數。任一變數惡化，都可能改變上述配置的攻守平衡——建議以此作為動態調整的觸發點：</a:t>
             </a:r>
@@ -11259,6 +11886,9 @@
                 <a:solidFill>
                   <a:srgbClr val="977B3B"/>
                 </a:solidFill>
+                <a:latin typeface="微軟正黑體"/>
+                <a:ea typeface="微軟正黑體"/>
+                <a:cs typeface="微軟正黑體"/>
               </a:rPr>
               <a:t>油價 → CPI</a:t>
             </a:r>
@@ -11300,6 +11930,9 @@
                 <a:solidFill>
                   <a:srgbClr val="222222"/>
                 </a:solidFill>
+                <a:latin typeface="微軟正黑體"/>
+                <a:ea typeface="微軟正黑體"/>
+                <a:cs typeface="微軟正黑體"/>
               </a:rPr>
               <a:t>能否壓回 3% 以下？花旗降息劇本 vs 美銀滯脹劇本的勝負手</a:t>
             </a:r>
@@ -11473,6 +12106,9 @@
                 <a:solidFill>
                   <a:srgbClr val="B14A42"/>
                 </a:solidFill>
+                <a:latin typeface="微軟正黑體"/>
+                <a:ea typeface="微軟正黑體"/>
+                <a:cs typeface="微軟正黑體"/>
               </a:rPr>
               <a:t>FOMC 路徑</a:t>
             </a:r>
@@ -11514,6 +12150,9 @@
                 <a:solidFill>
                   <a:srgbClr val="222222"/>
                 </a:solidFill>
+                <a:latin typeface="微軟正黑體"/>
+                <a:ea typeface="微軟正黑體"/>
+                <a:cs typeface="微軟正黑體"/>
               </a:rPr>
               <a:t>10 月加息已定價；美銀看 3 碼、德銀 2 碼，花旗逆勢看降息</a:t>
             </a:r>
@@ -11687,6 +12326,9 @@
                 <a:solidFill>
                   <a:srgbClr val="235173"/>
                 </a:solidFill>
+                <a:latin typeface="微軟正黑體"/>
+                <a:ea typeface="微軟正黑體"/>
+                <a:cs typeface="微軟正黑體"/>
               </a:rPr>
               <a:t>10 年期美債</a:t>
             </a:r>
@@ -11728,6 +12370,9 @@
                 <a:solidFill>
                   <a:srgbClr val="222222"/>
                 </a:solidFill>
+                <a:latin typeface="微軟正黑體"/>
+                <a:ea typeface="微軟正黑體"/>
+                <a:cs typeface="微軟正黑體"/>
               </a:rPr>
               <a:t>逼近 5% ＝股市紅線；曲線熊陡、財政赤字與長端供給壓力</a:t>
             </a:r>
@@ -11901,6 +12546,9 @@
                 <a:solidFill>
                   <a:srgbClr val="977B3B"/>
                 </a:solidFill>
+                <a:latin typeface="微軟正黑體"/>
+                <a:ea typeface="微軟正黑體"/>
+                <a:cs typeface="微軟正黑體"/>
               </a:rPr>
               <a:t>AI 盈餘 / 資本開支</a:t>
             </a:r>
@@ -11942,6 +12590,9 @@
                 <a:solidFill>
                   <a:srgbClr val="222222"/>
                 </a:solidFill>
+                <a:latin typeface="微軟正黑體"/>
+                <a:ea typeface="微軟正黑體"/>
+                <a:cs typeface="微軟正黑體"/>
               </a:rPr>
               <a:t>2027 雲廠商 capex 看破 1 兆；盈餘可持續性是估值關鍵</a:t>
             </a:r>
@@ -12115,6 +12766,9 @@
                 <a:solidFill>
                   <a:srgbClr val="235173"/>
                 </a:solidFill>
+                <a:latin typeface="微軟正黑體"/>
+                <a:ea typeface="微軟正黑體"/>
+                <a:cs typeface="微軟正黑體"/>
               </a:rPr>
               <a:t>擁擠度去化</a:t>
             </a:r>
@@ -12156,6 +12810,9 @@
                 <a:solidFill>
                   <a:srgbClr val="222222"/>
                 </a:solidFill>
+                <a:latin typeface="微軟正黑體"/>
+                <a:ea typeface="微軟正黑體"/>
+                <a:cs typeface="微軟正黑體"/>
               </a:rPr>
               <a:t>做多半導體 / Mag 7 若鬆動，恐引發連鎖去槓桿與波動放大</a:t>
             </a:r>
@@ -12329,6 +12986,9 @@
                 <a:solidFill>
                   <a:srgbClr val="B14A42"/>
                 </a:solidFill>
+                <a:latin typeface="微軟正黑體"/>
+                <a:ea typeface="微軟正黑體"/>
+                <a:cs typeface="微軟正黑體"/>
               </a:rPr>
               <a:t>政治 / 日圓</a:t>
             </a:r>
@@ -12370,6 +13030,9 @@
                 <a:solidFill>
                   <a:srgbClr val="222222"/>
                 </a:solidFill>
+                <a:latin typeface="微軟正黑體"/>
+                <a:ea typeface="微軟正黑體"/>
+                <a:cs typeface="微軟正黑體"/>
               </a:rPr>
               <a:t>11 月中期選舉「股債匯三殺」風險；日圓 carry 平倉尾部</a:t>
             </a:r>
@@ -12455,6 +13118,9 @@
                 <a:solidFill>
                   <a:srgbClr val="FFFFFF"/>
                 </a:solidFill>
+                <a:latin typeface="微軟正黑體"/>
+                <a:ea typeface="微軟正黑體"/>
+                <a:cs typeface="微軟正黑體"/>
               </a:rPr>
               <a:t>底線：基本面仍穩，但市場容錯率低 —— 增持盈餘確定性、控制集中與槓桿，緊盯油價與利率兩大搖擺因子。</a:t>
             </a:r>
@@ -12518,14 +13184,14 @@
     </a:clrScheme>
     <a:fontScheme name="Tw Cen MT">
       <a:majorFont>
-        <a:latin typeface="Tw Cen MT" panose="020B0602020104020603"/>
-        <a:ea typeface=""/>
-        <a:cs typeface=""/>
+        <a:latin typeface="微軟正黑體" panose="020B0602020104020603"/>
+        <a:ea typeface="微軟正黑體"/>
+        <a:cs typeface="微軟正黑體"/>
         <a:font script="Grek" typeface="Calibri"/>
         <a:font script="Cyrl" typeface="Calibri"/>
         <a:font script="Jpan" typeface="HGPｺﾞｼｯｸE"/>
         <a:font script="Hang" typeface="HY얕은샘물M"/>
-        <a:font script="Hans" typeface="华文仿宋"/>
+        <a:font script="Hans" typeface="微軟正黑體"/>
         <a:font script="Hant" typeface="微軟正黑體"/>
         <a:font script="Arab" typeface="Arial"/>
         <a:font script="Hebr" typeface="Levenim MT"/>
@@ -12555,14 +13221,14 @@
         <a:font script="Geor" typeface="Sylfaen"/>
       </a:majorFont>
       <a:minorFont>
-        <a:latin typeface="Tw Cen MT" panose="020B0602020104020603"/>
-        <a:ea typeface=""/>
-        <a:cs typeface=""/>
+        <a:latin typeface="微軟正黑體" panose="020B0602020104020603"/>
+        <a:ea typeface="微軟正黑體"/>
+        <a:cs typeface="微軟正黑體"/>
         <a:font script="Grek" typeface="Calibri"/>
         <a:font script="Cyrl" typeface="Calibri"/>
         <a:font script="Jpan" typeface="HGPｺﾞｼｯｸE"/>
         <a:font script="Hang" typeface="HY얕은샘물M"/>
-        <a:font script="Hans" typeface="华文仿宋"/>
+        <a:font script="Hans" typeface="微軟正黑體"/>
         <a:font script="Hant" typeface="微軟正黑體"/>
         <a:font script="Arab" typeface="Arial"/>
         <a:font script="Hebr" typeface="Levenim MT"/>

</xml_diff>